<commit_message>
update day 1 pptx update day 2 finance scripts and ppts
</commit_message>
<xml_diff>
--- a/lessons/day2-finance/B_finance_harvard.pptx
+++ b/lessons/day2-finance/B_finance_harvard.pptx
@@ -4600,7 +4600,7 @@
               <a:buNone/>
             </a:pPr>
             <a:r>
-              <a:rPr lang="en-US" sz="3200" b="1" dirty="0">
+              <a:rPr lang="en-US" sz="2800" b="1" dirty="0">
                 <a:solidFill>
                   <a:srgbClr val="293352"/>
                 </a:solidFill>
@@ -4608,9 +4608,9 @@
                 <a:ea typeface="Arial" pitchFamily="34" charset="-122"/>
                 <a:cs typeface="Arial" pitchFamily="34" charset="-120"/>
               </a:rPr>
-              <a:t>Why the Worked Example Does the Heavy Lifting</a:t>
-            </a:r>
-            <a:endParaRPr lang="en-US" sz="3200" dirty="0"/>
+              <a:t>LLMs are great at Named Entity Recognition with instructions</a:t>
+            </a:r>
+            <a:endParaRPr lang="en-US" sz="2800" dirty="0"/>
           </a:p>
         </p:txBody>
       </p:sp>
@@ -4810,13 +4810,16 @@
                 <a:solidFill>
                   <a:srgbClr val="293352"/>
                 </a:solidFill>
-                <a:latin typeface="Arial" pitchFamily="34" charset="0"/>
+                <a:latin typeface="Consolas" panose="020B0609020204030204" pitchFamily="49" charset="0"/>
                 <a:ea typeface="Courier New" pitchFamily="34" charset="-122"/>
-                <a:cs typeface="Courier New" pitchFamily="34" charset="-120"/>
+                <a:cs typeface="Consolas" panose="020B0609020204030204" pitchFamily="49" charset="0"/>
               </a:rPr>
               <a:t>{</a:t>
             </a:r>
-            <a:endParaRPr lang="en-US" sz="1000" dirty="0"/>
+            <a:endParaRPr lang="en-US" sz="1000" dirty="0">
+              <a:latin typeface="Consolas" panose="020B0609020204030204" pitchFamily="49" charset="0"/>
+              <a:cs typeface="Consolas" panose="020B0609020204030204" pitchFamily="49" charset="0"/>
+            </a:endParaRPr>
           </a:p>
           <a:p>
             <a:pPr marL="0" indent="0">
@@ -4827,13 +4830,16 @@
                 <a:solidFill>
                   <a:srgbClr val="293352"/>
                 </a:solidFill>
-                <a:latin typeface="Arial" pitchFamily="34" charset="0"/>
+                <a:latin typeface="Consolas" panose="020B0609020204030204" pitchFamily="49" charset="0"/>
                 <a:ea typeface="Courier New" pitchFamily="34" charset="-122"/>
-                <a:cs typeface="Courier New" pitchFamily="34" charset="-120"/>
+                <a:cs typeface="Consolas" panose="020B0609020204030204" pitchFamily="49" charset="0"/>
               </a:rPr>
               <a:t>  "companies": ["Microsoft", "Deloitte"],</a:t>
             </a:r>
-            <a:endParaRPr lang="en-US" sz="1000" dirty="0"/>
+            <a:endParaRPr lang="en-US" sz="1000" dirty="0">
+              <a:latin typeface="Consolas" panose="020B0609020204030204" pitchFamily="49" charset="0"/>
+              <a:cs typeface="Consolas" panose="020B0609020204030204" pitchFamily="49" charset="0"/>
+            </a:endParaRPr>
           </a:p>
           <a:p>
             <a:pPr marL="0" indent="0">
@@ -4844,13 +4850,16 @@
                 <a:solidFill>
                   <a:srgbClr val="293352"/>
                 </a:solidFill>
-                <a:latin typeface="Arial" pitchFamily="34" charset="0"/>
+                <a:latin typeface="Consolas" panose="020B0609020204030204" pitchFamily="49" charset="0"/>
                 <a:ea typeface="Courier New" pitchFamily="34" charset="-122"/>
-                <a:cs typeface="Courier New" pitchFamily="34" charset="-120"/>
+                <a:cs typeface="Consolas" panose="020B0609020204030204" pitchFamily="49" charset="0"/>
               </a:rPr>
               <a:t>  "executives": [{"name":"Tim Cook", "role":"CEO"}],</a:t>
             </a:r>
-            <a:endParaRPr lang="en-US" sz="1000" dirty="0"/>
+            <a:endParaRPr lang="en-US" sz="1000" dirty="0">
+              <a:latin typeface="Consolas" panose="020B0609020204030204" pitchFamily="49" charset="0"/>
+              <a:cs typeface="Consolas" panose="020B0609020204030204" pitchFamily="49" charset="0"/>
+            </a:endParaRPr>
           </a:p>
           <a:p>
             <a:pPr marL="0" indent="0">
@@ -4861,13 +4870,16 @@
                 <a:solidFill>
                   <a:srgbClr val="293352"/>
                 </a:solidFill>
-                <a:latin typeface="Arial" pitchFamily="34" charset="0"/>
+                <a:latin typeface="Consolas" panose="020B0609020204030204" pitchFamily="49" charset="0"/>
                 <a:ea typeface="Courier New" pitchFamily="34" charset="-122"/>
-                <a:cs typeface="Courier New" pitchFamily="34" charset="-120"/>
+                <a:cs typeface="Consolas" panose="020B0609020204030204" pitchFamily="49" charset="0"/>
               </a:rPr>
               <a:t>  "products": ["iPhone", "Services", "Windows PCs"],</a:t>
             </a:r>
-            <a:endParaRPr lang="en-US" sz="1000" dirty="0"/>
+            <a:endParaRPr lang="en-US" sz="1000" dirty="0">
+              <a:latin typeface="Consolas" panose="020B0609020204030204" pitchFamily="49" charset="0"/>
+              <a:cs typeface="Consolas" panose="020B0609020204030204" pitchFamily="49" charset="0"/>
+            </a:endParaRPr>
           </a:p>
           <a:p>
             <a:pPr marL="0" indent="0">
@@ -4878,13 +4890,16 @@
                 <a:solidFill>
                   <a:srgbClr val="293352"/>
                 </a:solidFill>
-                <a:latin typeface="Arial" pitchFamily="34" charset="0"/>
+                <a:latin typeface="Consolas" panose="020B0609020204030204" pitchFamily="49" charset="0"/>
                 <a:ea typeface="Courier New" pitchFamily="34" charset="-122"/>
-                <a:cs typeface="Courier New" pitchFamily="34" charset="-120"/>
+                <a:cs typeface="Consolas" panose="020B0609020204030204" pitchFamily="49" charset="0"/>
               </a:rPr>
               <a:t>  "financial_figures": [</a:t>
             </a:r>
-            <a:endParaRPr lang="en-US" sz="1000" dirty="0"/>
+            <a:endParaRPr lang="en-US" sz="1000" dirty="0">
+              <a:latin typeface="Consolas" panose="020B0609020204030204" pitchFamily="49" charset="0"/>
+              <a:cs typeface="Consolas" panose="020B0609020204030204" pitchFamily="49" charset="0"/>
+            </a:endParaRPr>
           </a:p>
           <a:p>
             <a:pPr marL="0" indent="0">
@@ -4895,13 +4910,16 @@
                 <a:solidFill>
                   <a:srgbClr val="293352"/>
                 </a:solidFill>
-                <a:latin typeface="Arial" pitchFamily="34" charset="0"/>
+                <a:latin typeface="Consolas" panose="020B0609020204030204" pitchFamily="49" charset="0"/>
                 <a:ea typeface="Courier New" pitchFamily="34" charset="-122"/>
-                <a:cs typeface="Courier New" pitchFamily="34" charset="-120"/>
+                <a:cs typeface="Consolas" panose="020B0609020204030204" pitchFamily="49" charset="0"/>
               </a:rPr>
               <a:t>    {"figure":"$51.3B", "metric":"iPhone revenue"},</a:t>
             </a:r>
-            <a:endParaRPr lang="en-US" sz="1000" dirty="0"/>
+            <a:endParaRPr lang="en-US" sz="1000" dirty="0">
+              <a:latin typeface="Consolas" panose="020B0609020204030204" pitchFamily="49" charset="0"/>
+              <a:cs typeface="Consolas" panose="020B0609020204030204" pitchFamily="49" charset="0"/>
+            </a:endParaRPr>
           </a:p>
           <a:p>
             <a:pPr marL="0" indent="0">
@@ -4912,13 +4930,16 @@
                 <a:solidFill>
                   <a:srgbClr val="293352"/>
                 </a:solidFill>
-                <a:latin typeface="Arial" pitchFamily="34" charset="0"/>
+                <a:latin typeface="Consolas" panose="020B0609020204030204" pitchFamily="49" charset="0"/>
                 <a:ea typeface="Courier New" pitchFamily="34" charset="-122"/>
-                <a:cs typeface="Courier New" pitchFamily="34" charset="-120"/>
+                <a:cs typeface="Consolas" panose="020B0609020204030204" pitchFamily="49" charset="0"/>
               </a:rPr>
               <a:t>    {"figure":"6%", "metric":"iPhone YoY growth"},</a:t>
             </a:r>
-            <a:endParaRPr lang="en-US" sz="1000" dirty="0"/>
+            <a:endParaRPr lang="en-US" sz="1000" dirty="0">
+              <a:latin typeface="Consolas" panose="020B0609020204030204" pitchFamily="49" charset="0"/>
+              <a:cs typeface="Consolas" panose="020B0609020204030204" pitchFamily="49" charset="0"/>
+            </a:endParaRPr>
           </a:p>
           <a:p>
             <a:pPr marL="0" indent="0">
@@ -4929,13 +4950,16 @@
                 <a:solidFill>
                   <a:srgbClr val="293352"/>
                 </a:solidFill>
-                <a:latin typeface="Arial" pitchFamily="34" charset="0"/>
+                <a:latin typeface="Consolas" panose="020B0609020204030204" pitchFamily="49" charset="0"/>
                 <a:ea typeface="Courier New" pitchFamily="34" charset="-122"/>
-                <a:cs typeface="Courier New" pitchFamily="34" charset="-120"/>
+                <a:cs typeface="Consolas" panose="020B0609020204030204" pitchFamily="49" charset="0"/>
               </a:rPr>
               <a:t>    {"figure":"$24.2B", "metric":"Services revenue"}</a:t>
             </a:r>
-            <a:endParaRPr lang="en-US" sz="1000" dirty="0"/>
+            <a:endParaRPr lang="en-US" sz="1000" dirty="0">
+              <a:latin typeface="Consolas" panose="020B0609020204030204" pitchFamily="49" charset="0"/>
+              <a:cs typeface="Consolas" panose="020B0609020204030204" pitchFamily="49" charset="0"/>
+            </a:endParaRPr>
           </a:p>
           <a:p>
             <a:pPr marL="0" indent="0">
@@ -4946,13 +4970,16 @@
                 <a:solidFill>
                   <a:srgbClr val="293352"/>
                 </a:solidFill>
-                <a:latin typeface="Arial" pitchFamily="34" charset="0"/>
+                <a:latin typeface="Consolas" panose="020B0609020204030204" pitchFamily="49" charset="0"/>
                 <a:ea typeface="Courier New" pitchFamily="34" charset="-122"/>
-                <a:cs typeface="Courier New" pitchFamily="34" charset="-120"/>
+                <a:cs typeface="Consolas" panose="020B0609020204030204" pitchFamily="49" charset="0"/>
               </a:rPr>
               <a:t>  ],</a:t>
             </a:r>
-            <a:endParaRPr lang="en-US" sz="1000" dirty="0"/>
+            <a:endParaRPr lang="en-US" sz="1000" dirty="0">
+              <a:latin typeface="Consolas" panose="020B0609020204030204" pitchFamily="49" charset="0"/>
+              <a:cs typeface="Consolas" panose="020B0609020204030204" pitchFamily="49" charset="0"/>
+            </a:endParaRPr>
           </a:p>
           <a:p>
             <a:pPr marL="0" indent="0">
@@ -4963,13 +4990,16 @@
                 <a:solidFill>
                   <a:srgbClr val="293352"/>
                 </a:solidFill>
-                <a:latin typeface="Arial" pitchFamily="34" charset="0"/>
+                <a:latin typeface="Consolas" panose="020B0609020204030204" pitchFamily="49" charset="0"/>
                 <a:ea typeface="Courier New" pitchFamily="34" charset="-122"/>
-                <a:cs typeface="Courier New" pitchFamily="34" charset="-120"/>
+                <a:cs typeface="Consolas" panose="020B0609020204030204" pitchFamily="49" charset="0"/>
               </a:rPr>
               <a:t>  "forward_looking_statements": [</a:t>
             </a:r>
-            <a:endParaRPr lang="en-US" sz="1000" dirty="0"/>
+            <a:endParaRPr lang="en-US" sz="1000" dirty="0">
+              <a:latin typeface="Consolas" panose="020B0609020204030204" pitchFamily="49" charset="0"/>
+              <a:cs typeface="Consolas" panose="020B0609020204030204" pitchFamily="49" charset="0"/>
+            </a:endParaRPr>
           </a:p>
           <a:p>
             <a:pPr marL="0" indent="0">
@@ -4980,13 +5010,16 @@
                 <a:solidFill>
                   <a:srgbClr val="293352"/>
                 </a:solidFill>
-                <a:latin typeface="Arial" pitchFamily="34" charset="0"/>
+                <a:latin typeface="Consolas" panose="020B0609020204030204" pitchFamily="49" charset="0"/>
                 <a:ea typeface="Courier New" pitchFamily="34" charset="-122"/>
-                <a:cs typeface="Courier New" pitchFamily="34" charset="-120"/>
+                <a:cs typeface="Consolas" panose="020B0609020204030204" pitchFamily="49" charset="0"/>
               </a:rPr>
               <a:t>    "we expect December quarter revenue growth to accelerate"</a:t>
             </a:r>
-            <a:endParaRPr lang="en-US" sz="1000" dirty="0"/>
+            <a:endParaRPr lang="en-US" sz="1000" dirty="0">
+              <a:latin typeface="Consolas" panose="020B0609020204030204" pitchFamily="49" charset="0"/>
+              <a:cs typeface="Consolas" panose="020B0609020204030204" pitchFamily="49" charset="0"/>
+            </a:endParaRPr>
           </a:p>
           <a:p>
             <a:pPr marL="0" indent="0">
@@ -4997,13 +5030,16 @@
                 <a:solidFill>
                   <a:srgbClr val="293352"/>
                 </a:solidFill>
-                <a:latin typeface="Arial" pitchFamily="34" charset="0"/>
+                <a:latin typeface="Consolas" panose="020B0609020204030204" pitchFamily="49" charset="0"/>
                 <a:ea typeface="Courier New" pitchFamily="34" charset="-122"/>
-                <a:cs typeface="Courier New" pitchFamily="34" charset="-120"/>
+                <a:cs typeface="Consolas" panose="020B0609020204030204" pitchFamily="49" charset="0"/>
               </a:rPr>
               <a:t>  ]</a:t>
             </a:r>
-            <a:endParaRPr lang="en-US" sz="1000" dirty="0"/>
+            <a:endParaRPr lang="en-US" sz="1000" dirty="0">
+              <a:latin typeface="Consolas" panose="020B0609020204030204" pitchFamily="49" charset="0"/>
+              <a:cs typeface="Consolas" panose="020B0609020204030204" pitchFamily="49" charset="0"/>
+            </a:endParaRPr>
           </a:p>
           <a:p>
             <a:pPr marL="0" indent="0">
@@ -5014,13 +5050,16 @@
                 <a:solidFill>
                   <a:srgbClr val="293352"/>
                 </a:solidFill>
-                <a:latin typeface="Arial" pitchFamily="34" charset="0"/>
+                <a:latin typeface="Consolas" panose="020B0609020204030204" pitchFamily="49" charset="0"/>
                 <a:ea typeface="Courier New" pitchFamily="34" charset="-122"/>
-                <a:cs typeface="Courier New" pitchFamily="34" charset="-120"/>
+                <a:cs typeface="Consolas" panose="020B0609020204030204" pitchFamily="49" charset="0"/>
               </a:rPr>
               <a:t>}</a:t>
             </a:r>
-            <a:endParaRPr lang="en-US" sz="1000" dirty="0"/>
+            <a:endParaRPr lang="en-US" sz="1000" dirty="0">
+              <a:latin typeface="Consolas" panose="020B0609020204030204" pitchFamily="49" charset="0"/>
+              <a:cs typeface="Consolas" panose="020B0609020204030204" pitchFamily="49" charset="0"/>
+            </a:endParaRPr>
           </a:p>
         </p:txBody>
       </p:sp>
@@ -5330,30 +5369,58 @@
                 <a:solidFill>
                   <a:srgbClr val="293352"/>
                 </a:solidFill>
-                <a:latin typeface="Arial" pitchFamily="34" charset="0"/>
+                <a:latin typeface="Consolas" panose="020B0609020204030204" pitchFamily="49" charset="0"/>
                 <a:ea typeface="Courier New" pitchFamily="34" charset="-122"/>
-                <a:cs typeface="Courier New" pitchFamily="34" charset="-120"/>
-              </a:rPr>
-              <a:t>executives = list(</a:t>
-            </a:r>
-            <a:endParaRPr lang="en-US" sz="1400" dirty="0"/>
-          </a:p>
-          <a:p>
-            <a:pPr marL="0" indent="0">
-              <a:buNone/>
-            </a:pPr>
+                <a:cs typeface="Consolas" panose="020B0609020204030204" pitchFamily="49" charset="0"/>
+              </a:rPr>
+              <a:t>executives = </a:t>
+            </a:r>
             <a:r>
               <a:rPr lang="en-US" sz="1400" dirty="0">
                 <a:solidFill>
+                  <a:srgbClr val="FF0000"/>
+                </a:solidFill>
+                <a:latin typeface="Consolas" panose="020B0609020204030204" pitchFamily="49" charset="0"/>
+                <a:ea typeface="Courier New" pitchFamily="34" charset="-122"/>
+                <a:cs typeface="Consolas" panose="020B0609020204030204" pitchFamily="49" charset="0"/>
+              </a:rPr>
+              <a:t>list</a:t>
+            </a:r>
+            <a:r>
+              <a:rPr lang="en-US" sz="1400" dirty="0">
+                <a:solidFill>
                   <a:srgbClr val="293352"/>
                 </a:solidFill>
-                <a:latin typeface="Arial" pitchFamily="34" charset="0"/>
+                <a:latin typeface="Consolas" panose="020B0609020204030204" pitchFamily="49" charset="0"/>
                 <a:ea typeface="Courier New" pitchFamily="34" charset="-122"/>
-                <a:cs typeface="Courier New" pitchFamily="34" charset="-120"/>
+                <a:cs typeface="Consolas" panose="020B0609020204030204" pitchFamily="49" charset="0"/>
+              </a:rPr>
+              <a:t>(</a:t>
+            </a:r>
+            <a:endParaRPr lang="en-US" sz="1400" dirty="0">
+              <a:latin typeface="Consolas" panose="020B0609020204030204" pitchFamily="49" charset="0"/>
+              <a:cs typeface="Consolas" panose="020B0609020204030204" pitchFamily="49" charset="0"/>
+            </a:endParaRPr>
+          </a:p>
+          <a:p>
+            <a:pPr marL="0" indent="0">
+              <a:buNone/>
+            </a:pPr>
+            <a:r>
+              <a:rPr lang="en-US" sz="1400" dirty="0">
+                <a:solidFill>
+                  <a:srgbClr val="293352"/>
+                </a:solidFill>
+                <a:latin typeface="Consolas" panose="020B0609020204030204" pitchFamily="49" charset="0"/>
+                <a:ea typeface="Courier New" pitchFamily="34" charset="-122"/>
+                <a:cs typeface="Consolas" panose="020B0609020204030204" pitchFamily="49" charset="0"/>
               </a:rPr>
               <a:t>  type = "array",</a:t>
             </a:r>
-            <a:endParaRPr lang="en-US" sz="1400" dirty="0"/>
+            <a:endParaRPr lang="en-US" sz="1400" dirty="0">
+              <a:latin typeface="Consolas" panose="020B0609020204030204" pitchFamily="49" charset="0"/>
+              <a:cs typeface="Consolas" panose="020B0609020204030204" pitchFamily="49" charset="0"/>
+            </a:endParaRPr>
           </a:p>
           <a:p>
             <a:pPr marL="0" indent="0">
@@ -5364,30 +5431,58 @@
                 <a:solidFill>
                   <a:srgbClr val="293352"/>
                 </a:solidFill>
-                <a:latin typeface="Arial" pitchFamily="34" charset="0"/>
+                <a:latin typeface="Consolas" panose="020B0609020204030204" pitchFamily="49" charset="0"/>
                 <a:ea typeface="Courier New" pitchFamily="34" charset="-122"/>
-                <a:cs typeface="Courier New" pitchFamily="34" charset="-120"/>
-              </a:rPr>
-              <a:t>  items = list(</a:t>
-            </a:r>
-            <a:endParaRPr lang="en-US" sz="1400" dirty="0"/>
-          </a:p>
-          <a:p>
-            <a:pPr marL="0" indent="0">
-              <a:buNone/>
-            </a:pPr>
+                <a:cs typeface="Consolas" panose="020B0609020204030204" pitchFamily="49" charset="0"/>
+              </a:rPr>
+              <a:t>  items = </a:t>
+            </a:r>
             <a:r>
               <a:rPr lang="en-US" sz="1400" dirty="0">
                 <a:solidFill>
+                  <a:srgbClr val="FF0000"/>
+                </a:solidFill>
+                <a:latin typeface="Consolas" panose="020B0609020204030204" pitchFamily="49" charset="0"/>
+                <a:ea typeface="Courier New" pitchFamily="34" charset="-122"/>
+                <a:cs typeface="Consolas" panose="020B0609020204030204" pitchFamily="49" charset="0"/>
+              </a:rPr>
+              <a:t>list</a:t>
+            </a:r>
+            <a:r>
+              <a:rPr lang="en-US" sz="1400" dirty="0">
+                <a:solidFill>
                   <a:srgbClr val="293352"/>
                 </a:solidFill>
-                <a:latin typeface="Arial" pitchFamily="34" charset="0"/>
+                <a:latin typeface="Consolas" panose="020B0609020204030204" pitchFamily="49" charset="0"/>
                 <a:ea typeface="Courier New" pitchFamily="34" charset="-122"/>
-                <a:cs typeface="Courier New" pitchFamily="34" charset="-120"/>
+                <a:cs typeface="Consolas" panose="020B0609020204030204" pitchFamily="49" charset="0"/>
+              </a:rPr>
+              <a:t>(</a:t>
+            </a:r>
+            <a:endParaRPr lang="en-US" sz="1400" dirty="0">
+              <a:latin typeface="Consolas" panose="020B0609020204030204" pitchFamily="49" charset="0"/>
+              <a:cs typeface="Consolas" panose="020B0609020204030204" pitchFamily="49" charset="0"/>
+            </a:endParaRPr>
+          </a:p>
+          <a:p>
+            <a:pPr marL="0" indent="0">
+              <a:buNone/>
+            </a:pPr>
+            <a:r>
+              <a:rPr lang="en-US" sz="1400" dirty="0">
+                <a:solidFill>
+                  <a:srgbClr val="293352"/>
+                </a:solidFill>
+                <a:latin typeface="Consolas" panose="020B0609020204030204" pitchFamily="49" charset="0"/>
+                <a:ea typeface="Courier New" pitchFamily="34" charset="-122"/>
+                <a:cs typeface="Consolas" panose="020B0609020204030204" pitchFamily="49" charset="0"/>
               </a:rPr>
               <a:t>    type = "object",</a:t>
             </a:r>
-            <a:endParaRPr lang="en-US" sz="1400" dirty="0"/>
+            <a:endParaRPr lang="en-US" sz="1400" dirty="0">
+              <a:latin typeface="Consolas" panose="020B0609020204030204" pitchFamily="49" charset="0"/>
+              <a:cs typeface="Consolas" panose="020B0609020204030204" pitchFamily="49" charset="0"/>
+            </a:endParaRPr>
           </a:p>
           <a:p>
             <a:pPr marL="0" indent="0">
@@ -5398,30 +5493,38 @@
                 <a:solidFill>
                   <a:srgbClr val="293352"/>
                 </a:solidFill>
-                <a:latin typeface="Arial" pitchFamily="34" charset="0"/>
+                <a:latin typeface="Consolas" panose="020B0609020204030204" pitchFamily="49" charset="0"/>
                 <a:ea typeface="Courier New" pitchFamily="34" charset="-122"/>
-                <a:cs typeface="Courier New" pitchFamily="34" charset="-120"/>
-              </a:rPr>
-              <a:t>    properties = list(</a:t>
-            </a:r>
-            <a:endParaRPr lang="en-US" sz="1400" dirty="0"/>
-          </a:p>
-          <a:p>
-            <a:pPr marL="0" indent="0">
-              <a:buNone/>
-            </a:pPr>
+                <a:cs typeface="Consolas" panose="020B0609020204030204" pitchFamily="49" charset="0"/>
+              </a:rPr>
+              <a:t>    properties = </a:t>
+            </a:r>
             <a:r>
               <a:rPr lang="en-US" sz="1400" dirty="0">
                 <a:solidFill>
+                  <a:srgbClr val="FF0000"/>
+                </a:solidFill>
+                <a:latin typeface="Consolas" panose="020B0609020204030204" pitchFamily="49" charset="0"/>
+                <a:ea typeface="Courier New" pitchFamily="34" charset="-122"/>
+                <a:cs typeface="Consolas" panose="020B0609020204030204" pitchFamily="49" charset="0"/>
+              </a:rPr>
+              <a:t>list</a:t>
+            </a:r>
+            <a:r>
+              <a:rPr lang="en-US" sz="1400" dirty="0">
+                <a:solidFill>
                   <a:srgbClr val="293352"/>
                 </a:solidFill>
-                <a:latin typeface="Arial" pitchFamily="34" charset="0"/>
+                <a:latin typeface="Consolas" panose="020B0609020204030204" pitchFamily="49" charset="0"/>
                 <a:ea typeface="Courier New" pitchFamily="34" charset="-122"/>
-                <a:cs typeface="Courier New" pitchFamily="34" charset="-120"/>
-              </a:rPr>
-              <a:t>      name = list(type = "string"),</a:t>
-            </a:r>
-            <a:endParaRPr lang="en-US" sz="1400" dirty="0"/>
+                <a:cs typeface="Consolas" panose="020B0609020204030204" pitchFamily="49" charset="0"/>
+              </a:rPr>
+              <a:t>(</a:t>
+            </a:r>
+            <a:endParaRPr lang="en-US" sz="1400" dirty="0">
+              <a:latin typeface="Consolas" panose="020B0609020204030204" pitchFamily="49" charset="0"/>
+              <a:cs typeface="Consolas" panose="020B0609020204030204" pitchFamily="49" charset="0"/>
+            </a:endParaRPr>
           </a:p>
           <a:p>
             <a:pPr marL="0" indent="0">
@@ -5432,30 +5535,100 @@
                 <a:solidFill>
                   <a:srgbClr val="293352"/>
                 </a:solidFill>
-                <a:latin typeface="Arial" pitchFamily="34" charset="0"/>
+                <a:latin typeface="Consolas" panose="020B0609020204030204" pitchFamily="49" charset="0"/>
                 <a:ea typeface="Courier New" pitchFamily="34" charset="-122"/>
-                <a:cs typeface="Courier New" pitchFamily="34" charset="-120"/>
-              </a:rPr>
-              <a:t>      role = list(type = "string")</a:t>
-            </a:r>
-            <a:endParaRPr lang="en-US" sz="1400" dirty="0"/>
-          </a:p>
-          <a:p>
-            <a:pPr marL="0" indent="0">
-              <a:buNone/>
-            </a:pPr>
+                <a:cs typeface="Consolas" panose="020B0609020204030204" pitchFamily="49" charset="0"/>
+              </a:rPr>
+              <a:t>      name = </a:t>
+            </a:r>
             <a:r>
               <a:rPr lang="en-US" sz="1400" dirty="0">
                 <a:solidFill>
+                  <a:srgbClr val="FF0000"/>
+                </a:solidFill>
+                <a:latin typeface="Consolas" panose="020B0609020204030204" pitchFamily="49" charset="0"/>
+                <a:ea typeface="Courier New" pitchFamily="34" charset="-122"/>
+                <a:cs typeface="Consolas" panose="020B0609020204030204" pitchFamily="49" charset="0"/>
+              </a:rPr>
+              <a:t>list</a:t>
+            </a:r>
+            <a:r>
+              <a:rPr lang="en-US" sz="1400" dirty="0">
+                <a:solidFill>
                   <a:srgbClr val="293352"/>
                 </a:solidFill>
-                <a:latin typeface="Arial" pitchFamily="34" charset="0"/>
+                <a:latin typeface="Consolas" panose="020B0609020204030204" pitchFamily="49" charset="0"/>
                 <a:ea typeface="Courier New" pitchFamily="34" charset="-122"/>
-                <a:cs typeface="Courier New" pitchFamily="34" charset="-120"/>
+                <a:cs typeface="Consolas" panose="020B0609020204030204" pitchFamily="49" charset="0"/>
+              </a:rPr>
+              <a:t>(type = "string"),</a:t>
+            </a:r>
+            <a:endParaRPr lang="en-US" sz="1400" dirty="0">
+              <a:latin typeface="Consolas" panose="020B0609020204030204" pitchFamily="49" charset="0"/>
+              <a:cs typeface="Consolas" panose="020B0609020204030204" pitchFamily="49" charset="0"/>
+            </a:endParaRPr>
+          </a:p>
+          <a:p>
+            <a:pPr marL="0" indent="0">
+              <a:buNone/>
+            </a:pPr>
+            <a:r>
+              <a:rPr lang="en-US" sz="1400" dirty="0">
+                <a:solidFill>
+                  <a:srgbClr val="293352"/>
+                </a:solidFill>
+                <a:latin typeface="Consolas" panose="020B0609020204030204" pitchFamily="49" charset="0"/>
+                <a:ea typeface="Courier New" pitchFamily="34" charset="-122"/>
+                <a:cs typeface="Consolas" panose="020B0609020204030204" pitchFamily="49" charset="0"/>
+              </a:rPr>
+              <a:t>      role = </a:t>
+            </a:r>
+            <a:r>
+              <a:rPr lang="en-US" sz="1400" dirty="0">
+                <a:solidFill>
+                  <a:srgbClr val="FF0000"/>
+                </a:solidFill>
+                <a:latin typeface="Consolas" panose="020B0609020204030204" pitchFamily="49" charset="0"/>
+                <a:ea typeface="Courier New" pitchFamily="34" charset="-122"/>
+                <a:cs typeface="Consolas" panose="020B0609020204030204" pitchFamily="49" charset="0"/>
+              </a:rPr>
+              <a:t>list</a:t>
+            </a:r>
+            <a:r>
+              <a:rPr lang="en-US" sz="1400" dirty="0">
+                <a:solidFill>
+                  <a:srgbClr val="293352"/>
+                </a:solidFill>
+                <a:latin typeface="Consolas" panose="020B0609020204030204" pitchFamily="49" charset="0"/>
+                <a:ea typeface="Courier New" pitchFamily="34" charset="-122"/>
+                <a:cs typeface="Consolas" panose="020B0609020204030204" pitchFamily="49" charset="0"/>
+              </a:rPr>
+              <a:t>(type = "string")</a:t>
+            </a:r>
+            <a:endParaRPr lang="en-US" sz="1400" dirty="0">
+              <a:latin typeface="Consolas" panose="020B0609020204030204" pitchFamily="49" charset="0"/>
+              <a:cs typeface="Consolas" panose="020B0609020204030204" pitchFamily="49" charset="0"/>
+            </a:endParaRPr>
+          </a:p>
+          <a:p>
+            <a:pPr marL="0" indent="0">
+              <a:buNone/>
+            </a:pPr>
+            <a:r>
+              <a:rPr lang="en-US" sz="1400" dirty="0">
+                <a:solidFill>
+                  <a:srgbClr val="293352"/>
+                </a:solidFill>
+                <a:latin typeface="Consolas" panose="020B0609020204030204" pitchFamily="49" charset="0"/>
+                <a:ea typeface="Courier New" pitchFamily="34" charset="-122"/>
+                <a:cs typeface="Consolas" panose="020B0609020204030204" pitchFamily="49" charset="0"/>
               </a:rPr>
               <a:t>    ),</a:t>
             </a:r>
-            <a:endParaRPr lang="en-US" sz="1400" dirty="0"/>
+            <a:endParaRPr lang="en-US" sz="1400" dirty="0">
+              <a:latin typeface="Consolas" panose="020B0609020204030204" pitchFamily="49" charset="0"/>
+              <a:cs typeface="Consolas" panose="020B0609020204030204" pitchFamily="49" charset="0"/>
+            </a:endParaRPr>
           </a:p>
           <a:p>
             <a:pPr marL="0" indent="0">
@@ -5466,30 +5639,58 @@
                 <a:solidFill>
                   <a:srgbClr val="293352"/>
                 </a:solidFill>
-                <a:latin typeface="Arial" pitchFamily="34" charset="0"/>
+                <a:latin typeface="Consolas" panose="020B0609020204030204" pitchFamily="49" charset="0"/>
                 <a:ea typeface="Courier New" pitchFamily="34" charset="-122"/>
-                <a:cs typeface="Courier New" pitchFamily="34" charset="-120"/>
-              </a:rPr>
-              <a:t>    required = list("name", "role"),</a:t>
-            </a:r>
-            <a:endParaRPr lang="en-US" sz="1400" dirty="0"/>
-          </a:p>
-          <a:p>
-            <a:pPr marL="0" indent="0">
-              <a:buNone/>
-            </a:pPr>
+                <a:cs typeface="Consolas" panose="020B0609020204030204" pitchFamily="49" charset="0"/>
+              </a:rPr>
+              <a:t>    required = </a:t>
+            </a:r>
             <a:r>
               <a:rPr lang="en-US" sz="1400" dirty="0">
                 <a:solidFill>
+                  <a:srgbClr val="FF0000"/>
+                </a:solidFill>
+                <a:latin typeface="Consolas" panose="020B0609020204030204" pitchFamily="49" charset="0"/>
+                <a:ea typeface="Courier New" pitchFamily="34" charset="-122"/>
+                <a:cs typeface="Consolas" panose="020B0609020204030204" pitchFamily="49" charset="0"/>
+              </a:rPr>
+              <a:t>list</a:t>
+            </a:r>
+            <a:r>
+              <a:rPr lang="en-US" sz="1400" dirty="0">
+                <a:solidFill>
                   <a:srgbClr val="293352"/>
                 </a:solidFill>
-                <a:latin typeface="Arial" pitchFamily="34" charset="0"/>
+                <a:latin typeface="Consolas" panose="020B0609020204030204" pitchFamily="49" charset="0"/>
                 <a:ea typeface="Courier New" pitchFamily="34" charset="-122"/>
-                <a:cs typeface="Courier New" pitchFamily="34" charset="-120"/>
+                <a:cs typeface="Consolas" panose="020B0609020204030204" pitchFamily="49" charset="0"/>
+              </a:rPr>
+              <a:t>("name", "role"),</a:t>
+            </a:r>
+            <a:endParaRPr lang="en-US" sz="1400" dirty="0">
+              <a:latin typeface="Consolas" panose="020B0609020204030204" pitchFamily="49" charset="0"/>
+              <a:cs typeface="Consolas" panose="020B0609020204030204" pitchFamily="49" charset="0"/>
+            </a:endParaRPr>
+          </a:p>
+          <a:p>
+            <a:pPr marL="0" indent="0">
+              <a:buNone/>
+            </a:pPr>
+            <a:r>
+              <a:rPr lang="en-US" sz="1400" dirty="0">
+                <a:solidFill>
+                  <a:srgbClr val="293352"/>
+                </a:solidFill>
+                <a:latin typeface="Consolas" panose="020B0609020204030204" pitchFamily="49" charset="0"/>
+                <a:ea typeface="Courier New" pitchFamily="34" charset="-122"/>
+                <a:cs typeface="Consolas" panose="020B0609020204030204" pitchFamily="49" charset="0"/>
               </a:rPr>
               <a:t>    additionalProperties = FALSE</a:t>
             </a:r>
-            <a:endParaRPr lang="en-US" sz="1400" dirty="0"/>
+            <a:endParaRPr lang="en-US" sz="1400" dirty="0">
+              <a:latin typeface="Consolas" panose="020B0609020204030204" pitchFamily="49" charset="0"/>
+              <a:cs typeface="Consolas" panose="020B0609020204030204" pitchFamily="49" charset="0"/>
+            </a:endParaRPr>
           </a:p>
           <a:p>
             <a:pPr marL="0" indent="0">
@@ -5500,13 +5701,16 @@
                 <a:solidFill>
                   <a:srgbClr val="293352"/>
                 </a:solidFill>
-                <a:latin typeface="Arial" pitchFamily="34" charset="0"/>
+                <a:latin typeface="Consolas" panose="020B0609020204030204" pitchFamily="49" charset="0"/>
                 <a:ea typeface="Courier New" pitchFamily="34" charset="-122"/>
-                <a:cs typeface="Courier New" pitchFamily="34" charset="-120"/>
+                <a:cs typeface="Consolas" panose="020B0609020204030204" pitchFamily="49" charset="0"/>
               </a:rPr>
               <a:t>  )</a:t>
             </a:r>
-            <a:endParaRPr lang="en-US" sz="1400" dirty="0"/>
+            <a:endParaRPr lang="en-US" sz="1400" dirty="0">
+              <a:latin typeface="Consolas" panose="020B0609020204030204" pitchFamily="49" charset="0"/>
+              <a:cs typeface="Consolas" panose="020B0609020204030204" pitchFamily="49" charset="0"/>
+            </a:endParaRPr>
           </a:p>
           <a:p>
             <a:pPr marL="0" indent="0">
@@ -5517,13 +5721,16 @@
                 <a:solidFill>
                   <a:srgbClr val="293352"/>
                 </a:solidFill>
-                <a:latin typeface="Arial" pitchFamily="34" charset="0"/>
+                <a:latin typeface="Consolas" panose="020B0609020204030204" pitchFamily="49" charset="0"/>
                 <a:ea typeface="Courier New" pitchFamily="34" charset="-122"/>
-                <a:cs typeface="Courier New" pitchFamily="34" charset="-120"/>
+                <a:cs typeface="Consolas" panose="020B0609020204030204" pitchFamily="49" charset="0"/>
               </a:rPr>
               <a:t>)</a:t>
             </a:r>
-            <a:endParaRPr lang="en-US" sz="1400" dirty="0"/>
+            <a:endParaRPr lang="en-US" sz="1400" dirty="0">
+              <a:latin typeface="Consolas" panose="020B0609020204030204" pitchFamily="49" charset="0"/>
+              <a:cs typeface="Consolas" panose="020B0609020204030204" pitchFamily="49" charset="0"/>
+            </a:endParaRPr>
           </a:p>
         </p:txBody>
       </p:sp>
@@ -6559,7 +6766,7 @@
                 <a:ea typeface="Arial" pitchFamily="34" charset="-122"/>
                 <a:cs typeface="Arial" pitchFamily="34" charset="-120"/>
               </a:rPr>
-              <a:t>Yours does.”</a:t>
+              <a:t>But ours does!”</a:t>
             </a:r>
             <a:endParaRPr lang="en-US" sz="2800" dirty="0"/>
           </a:p>
@@ -9391,7 +9598,7 @@
                 <a:ea typeface="Arial" pitchFamily="34" charset="-122"/>
                 <a:cs typeface="Arial" pitchFamily="34" charset="-120"/>
               </a:rPr>
-              <a:t>Bridge to Hour 3: The SPA Build</a:t>
+              <a:t>Bridge to your new SPA.  Create another application.</a:t>
             </a:r>
             <a:endParaRPr lang="en-US" sz="3200" dirty="0"/>
           </a:p>
@@ -9622,7 +9829,7 @@
                 <a:ea typeface="Arial" pitchFamily="34" charset="-122"/>
                 <a:cs typeface="Arial" pitchFamily="34" charset="-120"/>
               </a:rPr>
-              <a:t>Hour 3 SPA equivalent</a:t>
+              <a:t>SPA equivalent</a:t>
             </a:r>
             <a:endParaRPr lang="en-US" sz="1300" dirty="0"/>
           </a:p>
@@ -9806,17 +10013,86 @@
               <a:buNone/>
             </a:pPr>
             <a:r>
-              <a:rPr lang="en-US" sz="1200" dirty="0">
+              <a:rPr lang="en-US" sz="1100" dirty="0">
                 <a:solidFill>
                   <a:srgbClr val="1E1E1E"/>
                 </a:solidFill>
                 <a:latin typeface="Arial" pitchFamily="34" charset="0"/>
-                <a:ea typeface="Arial" pitchFamily="34" charset="-122"/>
-                <a:cs typeface="Arial" pitchFamily="34" charset="-120"/>
-              </a:rPr>
-              <a:t>fetch() in the browser</a:t>
-            </a:r>
-            <a:endParaRPr lang="en-US" sz="1200" dirty="0"/>
+                <a:cs typeface="Arial" pitchFamily="34" charset="-120"/>
+              </a:rPr>
+              <a:t>Share unauthenticated </a:t>
+            </a:r>
+            <a:r>
+              <a:rPr lang="en-US" sz="1100" dirty="0" err="1">
+                <a:solidFill>
+                  <a:srgbClr val="1E1E1E"/>
+                </a:solidFill>
+                <a:latin typeface="Arial" pitchFamily="34" charset="0"/>
+                <a:cs typeface="Arial" pitchFamily="34" charset="-120"/>
+              </a:rPr>
+              <a:t>riskline</a:t>
+            </a:r>
+            <a:r>
+              <a:rPr lang="en-US" sz="1100" dirty="0">
+                <a:solidFill>
+                  <a:srgbClr val="1E1E1E"/>
+                </a:solidFill>
+                <a:latin typeface="Arial" pitchFamily="34" charset="0"/>
+                <a:cs typeface="Arial" pitchFamily="34" charset="-120"/>
+              </a:rPr>
+              <a:t> API URL</a:t>
+            </a:r>
+          </a:p>
+          <a:p>
+            <a:pPr marL="0" indent="0">
+              <a:buNone/>
+            </a:pPr>
+            <a:r>
+              <a:rPr lang="en-US" sz="1100" dirty="0">
+                <a:solidFill>
+                  <a:srgbClr val="1E1E1E"/>
+                </a:solidFill>
+                <a:latin typeface="Arial" pitchFamily="34" charset="0"/>
+                <a:cs typeface="Arial" pitchFamily="34" charset="-120"/>
+              </a:rPr>
+              <a:t>Add </a:t>
+            </a:r>
+            <a:r>
+              <a:rPr lang="en-US" sz="1100" dirty="0" err="1">
+                <a:solidFill>
+                  <a:srgbClr val="1E1E1E"/>
+                </a:solidFill>
+                <a:latin typeface="Arial" pitchFamily="34" charset="0"/>
+                <a:cs typeface="Arial" pitchFamily="34" charset="-120"/>
+              </a:rPr>
+              <a:t>newsAPI</a:t>
+            </a:r>
+            <a:r>
+              <a:rPr lang="en-US" sz="1100" dirty="0">
+                <a:solidFill>
+                  <a:srgbClr val="1E1E1E"/>
+                </a:solidFill>
+                <a:latin typeface="Arial" pitchFamily="34" charset="0"/>
+                <a:cs typeface="Arial" pitchFamily="34" charset="-120"/>
+              </a:rPr>
+              <a:t> key input</a:t>
+            </a:r>
+          </a:p>
+          <a:p>
+            <a:pPr marL="0" indent="0">
+              <a:buNone/>
+            </a:pPr>
+            <a:r>
+              <a:rPr lang="en-US" sz="1100" dirty="0">
+                <a:solidFill>
+                  <a:srgbClr val="1E1E1E"/>
+                </a:solidFill>
+                <a:latin typeface="Arial" pitchFamily="34" charset="0"/>
+                <a:cs typeface="Arial" pitchFamily="34" charset="-120"/>
+              </a:rPr>
+              <a:t>Describe the headline to perplexity workflow</a:t>
+            </a:r>
+            <a:endParaRPr lang="en-US" sz="1100" dirty="0"/>
           </a:p>
         </p:txBody>
       </p:sp>
@@ -10006,7 +10282,29 @@
                 <a:ea typeface="Arial" pitchFamily="34" charset="-122"/>
                 <a:cs typeface="Arial" pitchFamily="34" charset="-120"/>
               </a:rPr>
-              <a:t>File upload or paste box</a:t>
+              <a:t>File upload or paste box of raw </a:t>
+            </a:r>
+            <a:r>
+              <a:rPr lang="en-US" sz="1200" dirty="0" err="1">
+                <a:solidFill>
+                  <a:srgbClr val="1E1E1E"/>
+                </a:solidFill>
+                <a:latin typeface="Arial" pitchFamily="34" charset="0"/>
+                <a:ea typeface="Arial" pitchFamily="34" charset="-122"/>
+                <a:cs typeface="Arial" pitchFamily="34" charset="-120"/>
+              </a:rPr>
+              <a:t>github</a:t>
+            </a:r>
+            <a:r>
+              <a:rPr lang="en-US" sz="1200" dirty="0">
+                <a:solidFill>
+                  <a:srgbClr val="1E1E1E"/>
+                </a:solidFill>
+                <a:latin typeface="Arial" pitchFamily="34" charset="0"/>
+                <a:ea typeface="Arial" pitchFamily="34" charset="-122"/>
+                <a:cs typeface="Arial" pitchFamily="34" charset="-120"/>
+              </a:rPr>
+              <a:t> URL, can add more than 1</a:t>
             </a:r>
             <a:endParaRPr lang="en-US" sz="1200" dirty="0"/>
           </a:p>
@@ -10198,7 +10496,7 @@
                 <a:ea typeface="Arial" pitchFamily="34" charset="-122"/>
                 <a:cs typeface="Arial" pitchFamily="34" charset="-120"/>
               </a:rPr>
-              <a:t>Context object in JS</a:t>
+              <a:t>Context object in JS; vibe code the context collection</a:t>
             </a:r>
             <a:endParaRPr lang="en-US" sz="1200" dirty="0"/>
           </a:p>
@@ -10390,7 +10688,7 @@
                 <a:ea typeface="Arial" pitchFamily="34" charset="-122"/>
                 <a:cs typeface="Arial" pitchFamily="34" charset="-120"/>
               </a:rPr>
-              <a:t>OpenRouter call, JS loop</a:t>
+              <a:t>OpenRouter call, JS loop on the data</a:t>
             </a:r>
             <a:endParaRPr lang="en-US" sz="1200" dirty="0"/>
           </a:p>
@@ -10582,7 +10880,7 @@
                 <a:ea typeface="Arial" pitchFamily="34" charset="-122"/>
                 <a:cs typeface="Arial" pitchFamily="34" charset="-120"/>
               </a:rPr>
-              <a:t>OpenRouter call, JS loop</a:t>
+              <a:t>OpenRouter call, JS loop on the data</a:t>
             </a:r>
             <a:endParaRPr lang="en-US" sz="1200" dirty="0"/>
           </a:p>
@@ -10766,7 +11064,7 @@
               <a:buNone/>
             </a:pPr>
             <a:r>
-              <a:rPr lang="en-US" sz="1200" dirty="0">
+              <a:rPr lang="en-US" sz="1100" dirty="0">
                 <a:solidFill>
                   <a:srgbClr val="1E1E1E"/>
                 </a:solidFill>
@@ -10776,7 +11074,22 @@
               </a:rPr>
               <a:t>Panel that renders it</a:t>
             </a:r>
-            <a:endParaRPr lang="en-US" sz="1200" dirty="0"/>
+          </a:p>
+          <a:p>
+            <a:pPr marL="0" indent="0">
+              <a:buNone/>
+            </a:pPr>
+            <a:r>
+              <a:rPr lang="en-US" sz="1100" dirty="0">
+                <a:solidFill>
+                  <a:srgbClr val="1E1E1E"/>
+                </a:solidFill>
+                <a:latin typeface="Arial" pitchFamily="34" charset="0"/>
+                <a:cs typeface="Arial" pitchFamily="34" charset="-120"/>
+              </a:rPr>
+              <a:t>Maybe a word cloud, table of data information &amp; improved research note along with older indicators</a:t>
+            </a:r>
+            <a:endParaRPr lang="en-US" sz="1100" dirty="0"/>
           </a:p>
         </p:txBody>
       </p:sp>
@@ -10953,7 +11266,7 @@
                 <a:ea typeface="Arial" pitchFamily="34" charset="-122"/>
                 <a:cs typeface="Arial" pitchFamily="34" charset="-120"/>
               </a:rPr>
-              <a:t>Hour 2: Three Scripts, One Artifact</a:t>
+              <a:t>Next up: Three Scripts, One Artifact</a:t>
             </a:r>
             <a:endParaRPr lang="en-US" sz="3200" dirty="0"/>
           </a:p>
@@ -14592,55 +14905,6 @@
             </a:r>
             <a:endParaRPr lang="en-US" sz="1300" dirty="0"/>
           </a:p>
-          <a:p>
-            <a:pPr marL="0" indent="0">
-              <a:spcAft>
-                <a:spcPts val="400"/>
-              </a:spcAft>
-              <a:buNone/>
-            </a:pPr>
-            <a:endParaRPr lang="en-US" sz="1300" dirty="0"/>
-          </a:p>
-          <a:p>
-            <a:pPr marL="0" indent="0">
-              <a:spcAft>
-                <a:spcPts val="400"/>
-              </a:spcAft>
-              <a:buNone/>
-            </a:pPr>
-            <a:r>
-              <a:rPr lang="en-US" sz="1500" b="1" dirty="0">
-                <a:solidFill>
-                  <a:srgbClr val="A51C30"/>
-                </a:solidFill>
-                <a:latin typeface="Arial" pitchFamily="34" charset="0"/>
-                <a:ea typeface="Arial" pitchFamily="34" charset="-122"/>
-                <a:cs typeface="Arial" pitchFamily="34" charset="-120"/>
-              </a:rPr>
-              <a:t>tryCatch outside the retry.</a:t>
-            </a:r>
-            <a:endParaRPr lang="en-US" sz="1300" dirty="0"/>
-          </a:p>
-          <a:p>
-            <a:pPr marL="0" indent="0">
-              <a:spcAft>
-                <a:spcPts val="400"/>
-              </a:spcAft>
-              <a:buNone/>
-            </a:pPr>
-            <a:r>
-              <a:rPr lang="en-US" sz="1300" dirty="0">
-                <a:solidFill>
-                  <a:srgbClr val="1E1E1E"/>
-                </a:solidFill>
-                <a:latin typeface="Arial" pitchFamily="34" charset="0"/>
-                <a:ea typeface="Arial" pitchFamily="34" charset="-122"/>
-                <a:cs typeface="Arial" pitchFamily="34" charset="-120"/>
-              </a:rPr>
-              <a:t>If a row still fails after all retries, we wrap it so ONE bad row does not kill the whole run. The loop keeps going.</a:t>
-            </a:r>
-            <a:endParaRPr lang="en-US" sz="1300" dirty="0"/>
-          </a:p>
         </p:txBody>
       </p:sp>
       <p:sp>
@@ -14697,13 +14961,16 @@
                 <a:solidFill>
                   <a:srgbClr val="293352"/>
                 </a:solidFill>
-                <a:latin typeface="Arial" pitchFamily="34" charset="0"/>
+                <a:latin typeface="Consolas" panose="020B0609020204030204" pitchFamily="49" charset="0"/>
                 <a:ea typeface="Courier New" pitchFamily="34" charset="-122"/>
-                <a:cs typeface="Courier New" pitchFamily="34" charset="-120"/>
+                <a:cs typeface="Consolas" panose="020B0609020204030204" pitchFamily="49" charset="0"/>
               </a:rPr>
               <a:t>req &lt;- request(OPENROUTER_URL)</a:t>
             </a:r>
-            <a:endParaRPr lang="en-US" sz="1200" dirty="0"/>
+            <a:endParaRPr lang="en-US" sz="1200" dirty="0">
+              <a:latin typeface="Consolas" panose="020B0609020204030204" pitchFamily="49" charset="0"/>
+              <a:cs typeface="Consolas" panose="020B0609020204030204" pitchFamily="49" charset="0"/>
+            </a:endParaRPr>
           </a:p>
           <a:p>
             <a:pPr marL="0" indent="0">
@@ -14714,13 +14981,16 @@
                 <a:solidFill>
                   <a:srgbClr val="293352"/>
                 </a:solidFill>
-                <a:latin typeface="Arial" pitchFamily="34" charset="0"/>
+                <a:latin typeface="Consolas" panose="020B0609020204030204" pitchFamily="49" charset="0"/>
                 <a:ea typeface="Courier New" pitchFamily="34" charset="-122"/>
-                <a:cs typeface="Courier New" pitchFamily="34" charset="-120"/>
+                <a:cs typeface="Consolas" panose="020B0609020204030204" pitchFamily="49" charset="0"/>
               </a:rPr>
               <a:t>req &lt;- req_headers(req,</a:t>
             </a:r>
-            <a:endParaRPr lang="en-US" sz="1200" dirty="0"/>
+            <a:endParaRPr lang="en-US" sz="1200" dirty="0">
+              <a:latin typeface="Consolas" panose="020B0609020204030204" pitchFamily="49" charset="0"/>
+              <a:cs typeface="Consolas" panose="020B0609020204030204" pitchFamily="49" charset="0"/>
+            </a:endParaRPr>
           </a:p>
           <a:p>
             <a:pPr marL="0" indent="0">
@@ -14731,13 +15001,16 @@
                 <a:solidFill>
                   <a:srgbClr val="293352"/>
                 </a:solidFill>
-                <a:latin typeface="Arial" pitchFamily="34" charset="0"/>
+                <a:latin typeface="Consolas" panose="020B0609020204030204" pitchFamily="49" charset="0"/>
                 <a:ea typeface="Courier New" pitchFamily="34" charset="-122"/>
-                <a:cs typeface="Courier New" pitchFamily="34" charset="-120"/>
+                <a:cs typeface="Consolas" panose="020B0609020204030204" pitchFamily="49" charset="0"/>
               </a:rPr>
               <a:t>  "Authorization" = paste("Bearer", key),</a:t>
             </a:r>
-            <a:endParaRPr lang="en-US" sz="1200" dirty="0"/>
+            <a:endParaRPr lang="en-US" sz="1200" dirty="0">
+              <a:latin typeface="Consolas" panose="020B0609020204030204" pitchFamily="49" charset="0"/>
+              <a:cs typeface="Consolas" panose="020B0609020204030204" pitchFamily="49" charset="0"/>
+            </a:endParaRPr>
           </a:p>
           <a:p>
             <a:pPr marL="0" indent="0">
@@ -14748,13 +15021,16 @@
                 <a:solidFill>
                   <a:srgbClr val="293352"/>
                 </a:solidFill>
-                <a:latin typeface="Arial" pitchFamily="34" charset="0"/>
+                <a:latin typeface="Consolas" panose="020B0609020204030204" pitchFamily="49" charset="0"/>
                 <a:ea typeface="Courier New" pitchFamily="34" charset="-122"/>
-                <a:cs typeface="Courier New" pitchFamily="34" charset="-120"/>
+                <a:cs typeface="Consolas" panose="020B0609020204030204" pitchFamily="49" charset="0"/>
               </a:rPr>
               <a:t>  "Content-Type" = "application/json"</a:t>
             </a:r>
-            <a:endParaRPr lang="en-US" sz="1200" dirty="0"/>
+            <a:endParaRPr lang="en-US" sz="1200" dirty="0">
+              <a:latin typeface="Consolas" panose="020B0609020204030204" pitchFamily="49" charset="0"/>
+              <a:cs typeface="Consolas" panose="020B0609020204030204" pitchFamily="49" charset="0"/>
+            </a:endParaRPr>
           </a:p>
           <a:p>
             <a:pPr marL="0" indent="0">
@@ -14765,13 +15041,16 @@
                 <a:solidFill>
                   <a:srgbClr val="293352"/>
                 </a:solidFill>
-                <a:latin typeface="Arial" pitchFamily="34" charset="0"/>
+                <a:latin typeface="Consolas" panose="020B0609020204030204" pitchFamily="49" charset="0"/>
                 <a:ea typeface="Courier New" pitchFamily="34" charset="-122"/>
-                <a:cs typeface="Courier New" pitchFamily="34" charset="-120"/>
+                <a:cs typeface="Consolas" panose="020B0609020204030204" pitchFamily="49" charset="0"/>
               </a:rPr>
               <a:t>)</a:t>
             </a:r>
-            <a:endParaRPr lang="en-US" sz="1200" dirty="0"/>
+            <a:endParaRPr lang="en-US" sz="1200" dirty="0">
+              <a:latin typeface="Consolas" panose="020B0609020204030204" pitchFamily="49" charset="0"/>
+              <a:cs typeface="Consolas" panose="020B0609020204030204" pitchFamily="49" charset="0"/>
+            </a:endParaRPr>
           </a:p>
           <a:p>
             <a:pPr marL="0" indent="0">
@@ -14782,13 +15061,16 @@
                 <a:solidFill>
                   <a:srgbClr val="293352"/>
                 </a:solidFill>
-                <a:latin typeface="Arial" pitchFamily="34" charset="0"/>
+                <a:latin typeface="Consolas" panose="020B0609020204030204" pitchFamily="49" charset="0"/>
                 <a:ea typeface="Courier New" pitchFamily="34" charset="-122"/>
-                <a:cs typeface="Courier New" pitchFamily="34" charset="-120"/>
+                <a:cs typeface="Consolas" panose="020B0609020204030204" pitchFamily="49" charset="0"/>
               </a:rPr>
               <a:t>req &lt;- req_body_raw(req,</a:t>
             </a:r>
-            <a:endParaRPr lang="en-US" sz="1200" dirty="0"/>
+            <a:endParaRPr lang="en-US" sz="1200" dirty="0">
+              <a:latin typeface="Consolas" panose="020B0609020204030204" pitchFamily="49" charset="0"/>
+              <a:cs typeface="Consolas" panose="020B0609020204030204" pitchFamily="49" charset="0"/>
+            </a:endParaRPr>
           </a:p>
           <a:p>
             <a:pPr marL="0" indent="0">
@@ -14799,13 +15081,16 @@
                 <a:solidFill>
                   <a:srgbClr val="293352"/>
                 </a:solidFill>
-                <a:latin typeface="Arial" pitchFamily="34" charset="0"/>
+                <a:latin typeface="Consolas" panose="020B0609020204030204" pitchFamily="49" charset="0"/>
                 <a:ea typeface="Courier New" pitchFamily="34" charset="-122"/>
-                <a:cs typeface="Courier New" pitchFamily="34" charset="-120"/>
+                <a:cs typeface="Consolas" panose="020B0609020204030204" pitchFamily="49" charset="0"/>
               </a:rPr>
               <a:t>  toJSON(request_body, auto_unbox = TRUE),</a:t>
             </a:r>
-            <a:endParaRPr lang="en-US" sz="1200" dirty="0"/>
+            <a:endParaRPr lang="en-US" sz="1200" dirty="0">
+              <a:latin typeface="Consolas" panose="020B0609020204030204" pitchFamily="49" charset="0"/>
+              <a:cs typeface="Consolas" panose="020B0609020204030204" pitchFamily="49" charset="0"/>
+            </a:endParaRPr>
           </a:p>
           <a:p>
             <a:pPr marL="0" indent="0">
@@ -14816,13 +15101,16 @@
                 <a:solidFill>
                   <a:srgbClr val="293352"/>
                 </a:solidFill>
-                <a:latin typeface="Arial" pitchFamily="34" charset="0"/>
+                <a:latin typeface="Consolas" panose="020B0609020204030204" pitchFamily="49" charset="0"/>
                 <a:ea typeface="Courier New" pitchFamily="34" charset="-122"/>
-                <a:cs typeface="Courier New" pitchFamily="34" charset="-120"/>
+                <a:cs typeface="Consolas" panose="020B0609020204030204" pitchFamily="49" charset="0"/>
               </a:rPr>
               <a:t>  type = "application/json")</a:t>
             </a:r>
-            <a:endParaRPr lang="en-US" sz="1200" dirty="0"/>
+            <a:endParaRPr lang="en-US" sz="1200" dirty="0">
+              <a:latin typeface="Consolas" panose="020B0609020204030204" pitchFamily="49" charset="0"/>
+              <a:cs typeface="Consolas" panose="020B0609020204030204" pitchFamily="49" charset="0"/>
+            </a:endParaRPr>
           </a:p>
           <a:p>
             <a:pPr marL="0" indent="0">
@@ -14833,13 +15121,16 @@
                 <a:solidFill>
                   <a:srgbClr val="293352"/>
                 </a:solidFill>
-                <a:latin typeface="Arial" pitchFamily="34" charset="0"/>
+                <a:latin typeface="Consolas" panose="020B0609020204030204" pitchFamily="49" charset="0"/>
                 <a:ea typeface="Courier New" pitchFamily="34" charset="-122"/>
-                <a:cs typeface="Courier New" pitchFamily="34" charset="-120"/>
+                <a:cs typeface="Consolas" panose="020B0609020204030204" pitchFamily="49" charset="0"/>
               </a:rPr>
               <a:t>req &lt;- req_timeout(req, 120)</a:t>
             </a:r>
-            <a:endParaRPr lang="en-US" sz="1200" dirty="0"/>
+            <a:endParaRPr lang="en-US" sz="1200" dirty="0">
+              <a:latin typeface="Consolas" panose="020B0609020204030204" pitchFamily="49" charset="0"/>
+              <a:cs typeface="Consolas" panose="020B0609020204030204" pitchFamily="49" charset="0"/>
+            </a:endParaRPr>
           </a:p>
           <a:p>
             <a:pPr marL="0" indent="0">
@@ -14850,13 +15141,16 @@
                 <a:solidFill>
                   <a:srgbClr val="293352"/>
                 </a:solidFill>
-                <a:latin typeface="Arial" pitchFamily="34" charset="0"/>
+                <a:latin typeface="Consolas" panose="020B0609020204030204" pitchFamily="49" charset="0"/>
                 <a:ea typeface="Courier New" pitchFamily="34" charset="-122"/>
-                <a:cs typeface="Courier New" pitchFamily="34" charset="-120"/>
+                <a:cs typeface="Consolas" panose="020B0609020204030204" pitchFamily="49" charset="0"/>
               </a:rPr>
               <a:t>req &lt;- req_retry(req,</a:t>
             </a:r>
-            <a:endParaRPr lang="en-US" sz="1200" dirty="0"/>
+            <a:endParaRPr lang="en-US" sz="1200" dirty="0">
+              <a:latin typeface="Consolas" panose="020B0609020204030204" pitchFamily="49" charset="0"/>
+              <a:cs typeface="Consolas" panose="020B0609020204030204" pitchFamily="49" charset="0"/>
+            </a:endParaRPr>
           </a:p>
           <a:p>
             <a:pPr marL="0" indent="0">
@@ -14867,13 +15161,16 @@
                 <a:solidFill>
                   <a:srgbClr val="293352"/>
                 </a:solidFill>
-                <a:latin typeface="Arial" pitchFamily="34" charset="0"/>
+                <a:latin typeface="Consolas" panose="020B0609020204030204" pitchFamily="49" charset="0"/>
                 <a:ea typeface="Courier New" pitchFamily="34" charset="-122"/>
-                <a:cs typeface="Courier New" pitchFamily="34" charset="-120"/>
+                <a:cs typeface="Consolas" panose="020B0609020204030204" pitchFamily="49" charset="0"/>
               </a:rPr>
               <a:t>  max_tries = 3,</a:t>
             </a:r>
-            <a:endParaRPr lang="en-US" sz="1200" dirty="0"/>
+            <a:endParaRPr lang="en-US" sz="1200" dirty="0">
+              <a:latin typeface="Consolas" panose="020B0609020204030204" pitchFamily="49" charset="0"/>
+              <a:cs typeface="Consolas" panose="020B0609020204030204" pitchFamily="49" charset="0"/>
+            </a:endParaRPr>
           </a:p>
           <a:p>
             <a:pPr marL="0" indent="0">
@@ -14884,19 +15181,25 @@
                 <a:solidFill>
                   <a:srgbClr val="293352"/>
                 </a:solidFill>
-                <a:latin typeface="Arial" pitchFamily="34" charset="0"/>
+                <a:latin typeface="Consolas" panose="020B0609020204030204" pitchFamily="49" charset="0"/>
                 <a:ea typeface="Courier New" pitchFamily="34" charset="-122"/>
-                <a:cs typeface="Courier New" pitchFamily="34" charset="-120"/>
+                <a:cs typeface="Consolas" panose="020B0609020204030204" pitchFamily="49" charset="0"/>
               </a:rPr>
               <a:t>  backoff = ~ 2 ^ .x)</a:t>
             </a:r>
-            <a:endParaRPr lang="en-US" sz="1200" dirty="0"/>
-          </a:p>
-          <a:p>
-            <a:pPr marL="0" indent="0">
-              <a:buNone/>
-            </a:pPr>
-            <a:endParaRPr lang="en-US" sz="1200" dirty="0"/>
+            <a:endParaRPr lang="en-US" sz="1200" dirty="0">
+              <a:latin typeface="Consolas" panose="020B0609020204030204" pitchFamily="49" charset="0"/>
+              <a:cs typeface="Consolas" panose="020B0609020204030204" pitchFamily="49" charset="0"/>
+            </a:endParaRPr>
+          </a:p>
+          <a:p>
+            <a:pPr marL="0" indent="0">
+              <a:buNone/>
+            </a:pPr>
+            <a:endParaRPr lang="en-US" sz="1200" dirty="0">
+              <a:latin typeface="Consolas" panose="020B0609020204030204" pitchFamily="49" charset="0"/>
+              <a:cs typeface="Consolas" panose="020B0609020204030204" pitchFamily="49" charset="0"/>
+            </a:endParaRPr>
           </a:p>
           <a:p>
             <a:pPr marL="0" indent="0">
@@ -14907,13 +15210,16 @@
                 <a:solidFill>
                   <a:srgbClr val="293352"/>
                 </a:solidFill>
-                <a:latin typeface="Arial" pitchFamily="34" charset="0"/>
+                <a:latin typeface="Consolas" panose="020B0609020204030204" pitchFamily="49" charset="0"/>
                 <a:ea typeface="Courier New" pitchFamily="34" charset="-122"/>
-                <a:cs typeface="Courier New" pitchFamily="34" charset="-120"/>
+                <a:cs typeface="Consolas" panose="020B0609020204030204" pitchFamily="49" charset="0"/>
               </a:rPr>
               <a:t>resp &lt;- req_perform(req)</a:t>
             </a:r>
-            <a:endParaRPr lang="en-US" sz="1200" dirty="0"/>
+            <a:endParaRPr lang="en-US" sz="1200" dirty="0">
+              <a:latin typeface="Consolas" panose="020B0609020204030204" pitchFamily="49" charset="0"/>
+              <a:cs typeface="Consolas" panose="020B0609020204030204" pitchFamily="49" charset="0"/>
+            </a:endParaRPr>
           </a:p>
         </p:txBody>
       </p:sp>
@@ -15129,7 +15435,7 @@
                 <a:ea typeface="Arial" pitchFamily="34" charset="-122"/>
                 <a:cs typeface="Arial" pitchFamily="34" charset="-120"/>
               </a:rPr>
-              <a:t>A CEO who speaks for a long time may use 10 positive phrases and 3 negative in 100 words. Another CEO uses the same counts in 1000 words. The first is more positive than the second. Raw counts hide this.</a:t>
+              <a:t>A CEO who speaks for a long time may use 10 positive phrases and 3 negative in 100 words. Another CEO uses the same counts in 1000 words. The first is more positive than the second, higher density of positive terms. Raw counts hide this.</a:t>
             </a:r>
             <a:endParaRPr lang="en-US" sz="1400" dirty="0"/>
           </a:p>
@@ -15318,56 +15624,6 @@
               <a:t>+0.007   (barely leaning)</a:t>
             </a:r>
             <a:endParaRPr lang="en-US" sz="1400" dirty="0"/>
-          </a:p>
-        </p:txBody>
-      </p:sp>
-      <p:sp>
-        <p:nvSpPr>
-          <p:cNvPr id="9" name="Text 7"/>
-          <p:cNvSpPr/>
-          <p:nvPr/>
-        </p:nvSpPr>
-        <p:spPr>
-          <a:xfrm>
-            <a:off x="457200" y="4572000"/>
-            <a:ext cx="11247120" cy="1280160"/>
-          </a:xfrm>
-          <a:prstGeom prst="rect">
-            <a:avLst/>
-          </a:prstGeom>
-          <a:noFill/>
-          <a:ln/>
-        </p:spPr>
-        <p:txBody>
-          <a:bodyPr wrap="square" lIns="0" tIns="0" rIns="0" bIns="0" rtlCol="0" anchor="t"/>
-          <a:lstStyle/>
-          <a:p>
-            <a:pPr marL="0" indent="0">
-              <a:buNone/>
-            </a:pPr>
-            <a:r>
-              <a:rPr lang="en-US" sz="1300" b="1" i="1" dirty="0">
-                <a:solidFill>
-                  <a:srgbClr val="A51C30"/>
-                </a:solidFill>
-                <a:latin typeface="Arial" pitchFamily="34" charset="0"/>
-                <a:ea typeface="Arial" pitchFamily="34" charset="-122"/>
-                <a:cs typeface="Arial" pitchFamily="34" charset="-120"/>
-              </a:rPr>
-              <a:t>Design choice: </a:t>
-            </a:r>
-            <a:r>
-              <a:rPr lang="en-US" sz="1300" i="1" dirty="0">
-                <a:solidFill>
-                  <a:srgbClr val="1E1E1E"/>
-                </a:solidFill>
-                <a:latin typeface="Arial" pitchFamily="34" charset="0"/>
-                <a:ea typeface="Arial" pitchFamily="34" charset="-122"/>
-                <a:cs typeface="Arial" pitchFamily="34" charset="-120"/>
-              </a:rPr>
-              <a:t>no numeric score reaches the reader. Density is used to derive a label, and to rank speakers. Students see labels, not scores. The arithmetic sits in the data frame for audit.</a:t>
-            </a:r>
-            <a:endParaRPr lang="en-US" sz="1300" dirty="0"/>
           </a:p>
         </p:txBody>
       </p:sp>

</xml_diff>